<commit_message>
Update docs and PPT with Cortex Code CLI + Snowsight usage tabs
README and presentation now reflect all 4 Cortex Code tabs including
CORTEX_CODE_CLI_USAGE_HISTORY and CORTEX_CODE_SNOWSIGHT_USAGE_HISTORY.

.... Generated with [Cortex Code](https://docs.snowflake.com/en/user-guide/cortex-code/cortex-code)

Co-Authored-By: Cortex Code <noreply@snowflake.com>
</commit_message>
<xml_diff>
--- a/Cortex_Cost_Governance_Presentation.pptx
+++ b/Cortex_Cost_Governance_Presentation.pptx
@@ -3677,6 +3677,36 @@
               </a:defRPr>
             </a:pPr>
             <a:r>
+              <a:t>   CORTEX_CODE_CLI_USAGE_HISTORY</a:t>
+            </a:r>
+          </a:p>
+          <a:p>
+            <a:pPr>
+              <a:spcAft>
+                <a:spcPts val="800"/>
+              </a:spcAft>
+              <a:defRPr sz="1500">
+                <a:solidFill>
+                  <a:srgbClr val="11274E"/>
+                </a:solidFill>
+              </a:defRPr>
+            </a:pPr>
+            <a:r>
+              <a:t>   CORTEX_CODE_SNOWSIGHT_USAGE_HISTORY</a:t>
+            </a:r>
+          </a:p>
+          <a:p>
+            <a:pPr>
+              <a:spcAft>
+                <a:spcPts val="800"/>
+              </a:spcAft>
+              <a:defRPr sz="1500">
+                <a:solidFill>
+                  <a:srgbClr val="11274E"/>
+                </a:solidFill>
+              </a:defRPr>
+            </a:pPr>
+            <a:r>
               <a:t>   CORTEX_SEARCH_DAILY_USAGE_HISTORY</a:t>
             </a:r>
           </a:p>
@@ -5381,11 +5411,11 @@
               </a:defRPr>
             </a:pPr>
             <a:r>
-              <a:t>AI_SERVICES credit tracking</a:t>
+              <a:t>AI_SERVICES credits, CLI +</a:t>
             </a:r>
             <a:br/>
             <a:r>
-              <a:t>and query-level analysis</a:t>
+              <a:t>Snowsight token usage, queries</a:t>
             </a:r>
           </a:p>
         </p:txBody>
@@ -6814,7 +6844,7 @@
               <a:spcAft>
                 <a:spcPts val="800"/>
               </a:spcAft>
-              <a:defRPr sz="1600">
+              <a:defRPr sz="1400">
                 <a:solidFill>
                   <a:srgbClr val="11274E"/>
                 </a:solidFill>
@@ -6829,7 +6859,7 @@
               <a:spcAft>
                 <a:spcPts val="800"/>
               </a:spcAft>
-              <a:defRPr sz="1600">
+              <a:defRPr sz="1400">
                 <a:solidFill>
                   <a:srgbClr val="11274E"/>
                 </a:solidFill>
@@ -6844,7 +6874,7 @@
               <a:spcAft>
                 <a:spcPts val="800"/>
               </a:spcAft>
-              <a:defRPr sz="1600">
+              <a:defRPr sz="1400">
                 <a:solidFill>
                   <a:srgbClr val="11274E"/>
                 </a:solidFill>
@@ -6859,34 +6889,19 @@
               <a:spcAft>
                 <a:spcPts val="800"/>
               </a:spcAft>
-              <a:defRPr sz="1600">
-                <a:solidFill>
-                  <a:srgbClr val="11274E"/>
-                </a:solidFill>
-              </a:defRPr>
-            </a:pPr>
-            <a:r>
-              <a:t>   Raw metering data table</a:t>
-            </a:r>
-          </a:p>
-          <a:p>
-            <a:pPr>
-              <a:spcAft>
-                <a:spcPts val="800"/>
-              </a:spcAft>
-              <a:defRPr sz="1600">
-                <a:solidFill>
-                  <a:srgbClr val="11274E"/>
-                </a:solidFill>
-              </a:defRPr>
-            </a:pPr>
-          </a:p>
-          <a:p>
-            <a:pPr>
-              <a:spcAft>
-                <a:spcPts val="800"/>
-              </a:spcAft>
-              <a:defRPr sz="1600">
+              <a:defRPr sz="1400">
+                <a:solidFill>
+                  <a:srgbClr val="11274E"/>
+                </a:solidFill>
+              </a:defRPr>
+            </a:pPr>
+          </a:p>
+          <a:p>
+            <a:pPr>
+              <a:spcAft>
+                <a:spcPts val="800"/>
+              </a:spcAft>
+              <a:defRPr sz="1400">
                 <a:solidFill>
                   <a:srgbClr val="11274E"/>
                 </a:solidFill>
@@ -6901,7 +6916,7 @@
               <a:spcAft>
                 <a:spcPts val="800"/>
               </a:spcAft>
-              <a:defRPr sz="1600">
+              <a:defRPr sz="1400">
                 <a:solidFill>
                   <a:srgbClr val="11274E"/>
                 </a:solidFill>
@@ -6916,7 +6931,7 @@
               <a:spcAft>
                 <a:spcPts val="800"/>
               </a:spcAft>
-              <a:defRPr sz="1600">
+              <a:defRPr sz="1400">
                 <a:solidFill>
                   <a:srgbClr val="11274E"/>
                 </a:solidFill>
@@ -6931,14 +6946,113 @@
               <a:spcAft>
                 <a:spcPts val="800"/>
               </a:spcAft>
-              <a:defRPr sz="1600">
-                <a:solidFill>
-                  <a:srgbClr val="11274E"/>
-                </a:solidFill>
-              </a:defRPr>
-            </a:pPr>
-            <a:r>
-              <a:t>   Query detail table (date, user, warehouse, count, credits, duration)</a:t>
+              <a:defRPr sz="1400">
+                <a:solidFill>
+                  <a:srgbClr val="11274E"/>
+                </a:solidFill>
+              </a:defRPr>
+            </a:pPr>
+          </a:p>
+          <a:p>
+            <a:pPr>
+              <a:spcAft>
+                <a:spcPts val="800"/>
+              </a:spcAft>
+              <a:defRPr sz="1400">
+                <a:solidFill>
+                  <a:srgbClr val="11274E"/>
+                </a:solidFill>
+              </a:defRPr>
+            </a:pPr>
+            <a:r>
+              <a:t>Tab 3: Cortex Code CLI Usage</a:t>
+            </a:r>
+          </a:p>
+          <a:p>
+            <a:pPr>
+              <a:spcAft>
+                <a:spcPts val="800"/>
+              </a:spcAft>
+              <a:defRPr sz="1400">
+                <a:solidFill>
+                  <a:srgbClr val="11274E"/>
+                </a:solidFill>
+              </a:defRPr>
+            </a:pPr>
+            <a:r>
+              <a:t>   Token credits, tokens, and request count KPIs</a:t>
+            </a:r>
+          </a:p>
+          <a:p>
+            <a:pPr>
+              <a:spcAft>
+                <a:spcPts val="800"/>
+              </a:spcAft>
+              <a:defRPr sz="1400">
+                <a:solidFill>
+                  <a:srgbClr val="11274E"/>
+                </a:solidFill>
+              </a:defRPr>
+            </a:pPr>
+            <a:r>
+              <a:t>   Daily CLI credit trend (area chart) + credits by user (bar chart)</a:t>
+            </a:r>
+          </a:p>
+          <a:p>
+            <a:pPr>
+              <a:spcAft>
+                <a:spcPts val="800"/>
+              </a:spcAft>
+              <a:defRPr sz="1400">
+                <a:solidFill>
+                  <a:srgbClr val="11274E"/>
+                </a:solidFill>
+              </a:defRPr>
+            </a:pPr>
+          </a:p>
+          <a:p>
+            <a:pPr>
+              <a:spcAft>
+                <a:spcPts val="800"/>
+              </a:spcAft>
+              <a:defRPr sz="1400">
+                <a:solidFill>
+                  <a:srgbClr val="11274E"/>
+                </a:solidFill>
+              </a:defRPr>
+            </a:pPr>
+            <a:r>
+              <a:t>Tab 4: Cortex Code Snowsight Usage</a:t>
+            </a:r>
+          </a:p>
+          <a:p>
+            <a:pPr>
+              <a:spcAft>
+                <a:spcPts val="800"/>
+              </a:spcAft>
+              <a:defRPr sz="1400">
+                <a:solidFill>
+                  <a:srgbClr val="11274E"/>
+                </a:solidFill>
+              </a:defRPr>
+            </a:pPr>
+            <a:r>
+              <a:t>   Token credits, tokens, and request count KPIs</a:t>
+            </a:r>
+          </a:p>
+          <a:p>
+            <a:pPr>
+              <a:spcAft>
+                <a:spcPts val="800"/>
+              </a:spcAft>
+              <a:defRPr sz="1400">
+                <a:solidFill>
+                  <a:srgbClr val="11274E"/>
+                </a:solidFill>
+              </a:defRPr>
+            </a:pPr>
+            <a:r>
+              <a:t>   Daily Snowsight credit trend (area chart) + credits by user (bar chart)</a:t>
             </a:r>
           </a:p>
         </p:txBody>
@@ -6973,7 +7087,7 @@
               </a:defRPr>
             </a:pPr>
             <a:r>
-              <a:t>Data Sources: METERING_DAILY_HISTORY (AI_SERVICES) + QUERY_HISTORY (ILIKE '%CORTEX%')</a:t>
+              <a:t>Data Sources: METERING_DAILY_HISTORY + QUERY_HISTORY + CORTEX_CODE_CLI_USAGE_HISTORY + CORTEX_CODE_SNOWSIGHT_USAGE_HISTORY</a:t>
             </a:r>
           </a:p>
         </p:txBody>

</xml_diff>